<commit_message>
fix prices and slide references across all templates
- remove all specific rupee prices, replace with "within budget"
- convert Rs/₹ amounts in jewellery competitors to dollar equivalents
- fix "next slide" → "slide 11" reference on slide 5 for all categories
- add price cleanup swap for clothing slide 4

Co-Authored-By: Claude Opus 4.6 (1M context) <noreply@anthropic.com>
</commit_message>
<xml_diff>
--- a/output/SS_Generic_Bags.pptx
+++ b/output/SS_Generic_Bags.pptx
@@ -9887,7 +9887,7 @@
                           <a:cs typeface="Inter"/>
                           <a:sym typeface="Inter"/>
                         </a:rPr>
-                        <a:t>waterproof, laptop sleeve, USB port, anti-theft, backpack under 3000</a:t>
+                        <a:t>waterproof, laptop sleeve, USB port, anti-theft, backpack, within budget</a:t>
                       </a:r>
                       <a:endParaRPr sz="1000" u="none" cap="none" strike="noStrike">
                         <a:latin typeface="Inter"/>
@@ -13768,7 +13768,7 @@
                 <a:cs typeface="Inter"/>
                 <a:sym typeface="Inter"/>
               </a:rPr>
-              <a:t>What an AI Shopping Assistant changes :  “I need a waterproof laptop backpack with USB charging port, anti-theft zippers, and a trolley sleeve under 3000”</a:t>
+              <a:t>What an AI Shopping Assistant changes :  “I need a waterproof laptop backpack with USB charging port, anti-theft zippers, and a trolley sleeve, within budget”</a:t>
             </a:r>
             <a:endParaRPr b="0" i="0" sz="1100" u="none" cap="none" strike="noStrike">
               <a:solidFill>
@@ -14657,7 +14657,7 @@
                 <a:cs typeface="Inter"/>
                 <a:sym typeface="Inter"/>
               </a:rPr>
-              <a:t>Unlike traditional search bars that only cater to keyword matching for direct queries like “tan leather tote” or “crossbody with bottle pocket”, AI chat assistants need to answer intent based queries like “I need a bag for gym and work” or “I want a carry-on that fits my 15-inch laptop”. They have to map buyer intent to keywords using a knowledge graph and then search the catalog for relevant products using keywords, refer to the diagram in the next slide for an example</a:t>
+              <a:t>Unlike traditional search bars that only cater to keyword matching for direct queries like “tan leather tote” or “crossbody with bottle pocket”, AI chat assistants need to answer intent based queries like “I need a bag for gym and work” or “I want a carry-on that fits my 15-inch laptop”. They have to map buyer intent to keywords using a knowledge graph and then search the catalog for relevant products using keywords, refer to the diagram on slide 11 for an example</a:t>
             </a:r>
             <a:endParaRPr b="0" i="0" sz="1200" u="none" cap="none" strike="noStrike">
               <a:solidFill>

</xml_diff>

<commit_message>
add category-specific table images on slide 4
each template now has its own "Shopper Says vs Keyword Search Hears"
table with category-relevant intent queries (e.g. electronics shows
"Laptop good for coding and light gaming", jewellery shows "Something
lightweight I can wear daily to office", etc.)

Co-Authored-By: Claude Opus 4.6 (1M context) <noreply@anthropic.com>
</commit_message>
<xml_diff>
--- a/output/SS_Generic_Bags.pptx
+++ b/output/SS_Generic_Bags.pptx
@@ -13935,16 +13935,17 @@
       </p:sp>
       <p:pic>
         <p:nvPicPr>
-          <p:cNvPr id="59" name="Google Shape;59;p4" title="Screenshot 2026-04-14 at 9.08.05 PM.png"/>
-          <p:cNvPicPr preferRelativeResize="0"/>
+          <p:cNvPr id="59" name="Picture 58" descr="bags_table.png"/>
+          <p:cNvPicPr>
+            <a:picLocks noChangeAspect="1"/>
+          </p:cNvPicPr>
           <p:nvPr/>
         </p:nvPicPr>
-        <p:blipFill rotWithShape="1">
-          <a:blip r:embed="rId3">
-            <a:alphaModFix/>
-          </a:blip>
-          <a:srcRect b="0" l="0" r="0" t="0"/>
-          <a:stretch/>
+        <p:blipFill>
+          <a:blip r:embed="rId4"/>
+          <a:stretch>
+            <a:fillRect/>
+          </a:stretch>
         </p:blipFill>
         <p:spPr>
           <a:xfrm>
@@ -13954,10 +13955,6 @@
           <a:prstGeom prst="rect">
             <a:avLst/>
           </a:prstGeom>
-          <a:noFill/>
-          <a:ln>
-            <a:noFill/>
-          </a:ln>
         </p:spPr>
       </p:pic>
     </p:spTree>

</xml_diff>